<commit_message>
Remove process references so the deck stands alone
Strip all wording that referenced how the deck was produced or what
was requested (expanded edition, redesign notes, workshop-narration
attributions) from slide text, speaker notes, and document properties.
Content and design are unchanged; the deck now reads as a standalone
presentation.

Co-Authored-By: Claude Fable 5 <noreply@anthropic.com>
Claude-Session: https://claude.ai/code/session_01W7sHcgPQdWXGF9Jbf6zJKc
</commit_message>
<xml_diff>
--- a/Research-Gaps-الفجوات-البحثية.pptx
+++ b/Research-Gaps-الفجوات-البحثية.pptx
@@ -523,7 +523,7 @@
           <a:lstStyle/>
           <a:p>
             <a:r>
-              <a:t>افتتاحية الورشة كما وردت في الشرح: أكثر الأسئلة التي تصل للمقدمة على الخاص هو: هل يمكن استخدام الذكاء الاصطناعي لإيجاد الفجوة البحثية؟ والجواب: نعم — والورشة تشرح كيف. الموضوع من أهم مواضيع البحث العلمي: الفجوة البحثية تعني ببساطة الشيء الذي لم تتم دراسته بشكل كافٍ بعد، أو النقطة التي لم يركّز عليها الباحثون بوضوح. سنتعلم في هذا العرض: ما هي الفجوة البحثية، لماذا تعتبر مهمة، أنواعها المختلفة، والأهم: كيف نكتشفها باستخدام أدوات الذكاء الاصطناعي. والهدف النهائي: أن يتمكن أي طالب أو باحث بعد هذا العرض من تحديد فجوة بحثية قوية بطريقة احترافية.</a:t>
+              <a:t>افتتاحية مقترحة: من أكثر الأسئلة التي تشغل الباحثين اليوم: هل يمكن استخدام الذكاء الاصطناعي لإيجاد الفجوة البحثية؟ والجواب: نعم — وهذا ما سنتعلمه معاً. الموضوع من أهم مواضيع البحث العلمي: الفجوة البحثية تعني ببساطة الشيء الذي لم تتم دراسته بشكل كافٍ بعد، أو النقطة التي لم يركّز عليها الباحثون بوضوح. سنتعلم في هذا العرض: ما هي الفجوة البحثية، لماذا تعتبر مهمة، أنواعها المختلفة، والأهم: كيف نكتشفها باستخدام أدوات الذكاء الاصطناعي. والهدف النهائي: أن يتمكن أي طالب أو باحث بعد هذا العرض من تحديد فجوة بحثية قوية بطريقة احترافية.</a:t>
             </a:r>
           </a:p>
         </p:txBody>
@@ -593,7 +593,7 @@
           <a:lstStyle/>
           <a:p>
             <a:r>
-              <a:t>الباحثون المحترفون لديهم استراتيجيات ذكية لاكتشاف الفجوات، كما عرضتها الورشة: (1) قراءة خاتمة الدراسات (Conclusion Section): الباحثون غالباً يذكرون اقتراحات مستقبلية صريحة — هذه فجوات جاهزة أوصى بها أصحاب الدراسات أنفسهم. (2) عمل Literature Mapping أو خريطة للأدبيات العلمية حسب السكان والمنهج والدولة والزمن — الفراغ في الخريطة يظهر بصرياً بدل التخمين. (3) البحث عن التناقضات بين النتائج — التضارب فرصة لبحث يحسم الخلاف. (4) ومن أفضل الأسئلة: What if — ماذا لو طبقنا الدراسة نفسها على فئة عمرية مختلفة أو دولة مختلفة؟ قالت الورشة نصاً: هنا غالباً نجد فجوة بحثية ممتازة.</a:t>
+              <a:t>الباحثون المحترفون لديهم استراتيجيات ذكية لاكتشاف الفجوات، وأهمها: (1) قراءة خاتمة الدراسات (Conclusion Section): الباحثون غالباً يذكرون اقتراحات مستقبلية صريحة — هذه فجوات جاهزة أوصى بها أصحاب الدراسات أنفسهم. (2) عمل Literature Mapping أو خريطة للأدبيات العلمية حسب السكان والمنهج والدولة والزمن — الفراغ في الخريطة يظهر بصرياً بدل التخمين. (3) البحث عن التناقضات بين النتائج — التضارب فرصة لبحث يحسم الخلاف. (4) ومن أفضل الأسئلة: What if — ماذا لو طبقنا الدراسة نفسها على فئة عمرية مختلفة أو دولة مختلفة؟ وهنا غالباً نجد فجوة بحثية ممتازة.</a:t>
             </a:r>
           </a:p>
         </p:txBody>
@@ -663,7 +663,7 @@
           <a:lstStyle/>
           <a:p>
             <a:r>
-              <a:t>أي باحث ناجح لا بد أن يستخدم التفكير النقدي، وفي الورشة إطار من ستة أسئلة: Who — من الذي تمت دراسته؟ What — ما المتغيرات؟ Where — أين صار البحث؟ When — متى نُشرت الدراسة؟ How — كيف تمت الدراسة؟ Why — لماذا توقفت وما حدودها؟ اطرح هذه الأسئلة على كل دراسة تقرؤها وستتكشف الفجوات تلقائياً. ومن المؤشرات المهمة أثناء القراءة عبارات مثل: This area has not been studied، وResults are conflicting، وThe sample does not represent — التقاط هذه العبارات في الأدبيات يقودك مباشرة إلى فجوات قابلة للبحث. وتختم الورشة بقاعدة مهمة: التفكير النقدي ليس معناه أن ننتقد الدراسات السابقة، بل أن نبني عليها ونطورها.</a:t>
+              <a:t>أي باحث ناجح لا بد أن يستخدم التفكير النقدي، وهناك إطار من ستة أسئلة: Who — من الذي تمت دراسته؟ What — ما المتغيرات؟ Where — أين صار البحث؟ When — متى نُشرت الدراسة؟ How — كيف تمت الدراسة؟ Why — لماذا توقفت وما حدودها؟ اطرح هذه الأسئلة على كل دراسة تقرؤها وستتكشف الفجوات تلقائياً. ومن المؤشرات المهمة أثناء القراءة عبارات مثل: This area has not been studied، وResults are conflicting، وThe sample does not represent — التقاط هذه العبارات في الأدبيات يقودك مباشرة إلى فجوات قابلة للبحث. وقاعدة مهمة: التفكير النقدي ليس معناه أن ننتقد الدراسات السابقة، بل أن نبني عليها ونطورها.</a:t>
             </a:r>
           </a:p>
         </p:txBody>
@@ -733,7 +733,7 @@
           <a:lstStyle/>
           <a:p>
             <a:r>
-              <a:t>ليست كل فجوة تعتبر قوية — كما نبهت الورشة. الفجوة القوية (Strong Research Gap) تكون: مدعومة بالأدلة من مراجعة حقيقية للأدبيات، محددة وقابلة للقياس، ولها قيمة علمية وعملية، إضافة إلى قابليتها للمعالجة بمنهجية واقعية وارتباطها بسياق محدد. أما الفجوة الضعيفة (Weak Gap) فتكون عامة جداً وغير واضحة. والمثال الذي ضربته الورشة يوضح الفرق تماماً: قولنا «الصحة النفسية لم تُدرس بشكل كافٍ» فجوة ضعيفة — عامة بلا حدود ويسهل دحضها. لكن قولنا «لا توجد دراسة حول تأثير الدراسة عن بعد على القلق عند طلاب الجامعات العربية بعد 2020» فجوة قوية واضحة وقابلة للبحث: فيها المتغير والفئة والسياق والزمن. احرص أن تكون صياغتك دائماً من النوع الثاني.</a:t>
+              <a:t>ليست كل فجوة تعتبر قوية. الفجوة القوية (Strong Research Gap) تكون: مدعومة بالأدلة من مراجعة حقيقية للأدبيات، محددة وقابلة للقياس، ولها قيمة علمية وعملية، إضافة إلى قابليتها للمعالجة بمنهجية واقعية وارتباطها بسياق محدد. أما الفجوة الضعيفة (Weak Gap) فتكون عامة جداً وغير واضحة. والمثال المقارن يوضح الفرق تماماً: قولنا «الصحة النفسية لم تُدرس بشكل كافٍ» فجوة ضعيفة — عامة بلا حدود ويسهل دحضها. لكن قولنا «لا توجد دراسة حول تأثير الدراسة عن بعد على القلق عند طلاب الجامعات العربية بعد 2020» فجوة قوية واضحة وقابلة للبحث: فيها المتغير والفئة والسياق والزمن. احرص أن تكون صياغتك دائماً من النوع الثاني.</a:t>
             </a:r>
           </a:p>
         </p:txBody>
@@ -803,7 +803,7 @@
           <a:lstStyle/>
           <a:p>
             <a:r>
-              <a:t>خارطة طريق تنفيذية تجمع كل ما سبق في مسار عملي واحد من سبع خطوات: (1) تضييق المجال إلى تخصص فرعي — يسهل حصر الأدبيات. (2) جمع 20–30 دراسة حديثة من آخر خمس سنوات. (3) البدء بقراءة الخاتمات وأقسام حدود الدراسة — كما أوصت الورشة، فهي منجم الفجوات الجاهزة. (4) بناء خريطة الأدبيات (Literature Mapping) حسب السكان والمنهج والدولة والزمن. (5) تظليل الفراغات والتناقضات — الفجوة تظهر بصرياً في الخريطة. (6) التحقق عبر أدوات الذكاء الاصطناعي (سير عمل Research Rabbit من الشريحة التاسعة) من أن الفجوة لم تُسد بدراسة أحدث. (7) الصياغة النهائية بجملة محددة قابلة للقياس. الزمن الواقعي للمسار كاملاً: من أسبوعين إلى أربعة أسابيع من العمل المنتظم.</a:t>
+              <a:t>خارطة طريق تنفيذية تجمع كل ما سبق في مسار عملي واحد من سبع خطوات: (1) تضييق المجال إلى تخصص فرعي — يسهل حصر الأدبيات. (2) جمع 20–30 دراسة حديثة من آخر خمس سنوات. (3) البدء بقراءة الخاتمات وأقسام حدود الدراسة — فهي منجم الفجوات الجاهزة. (4) بناء خريطة الأدبيات (Literature Mapping) حسب السكان والمنهج والدولة والزمن. (5) تظليل الفراغات والتناقضات — الفجوة تظهر بصرياً في الخريطة. (6) التحقق عبر أدوات الذكاء الاصطناعي (سير عمل Research Rabbit من الشريحة التاسعة) من أن الفجوة لم تُسد بدراسة أحدث. (7) الصياغة النهائية بجملة محددة قابلة للقياس. الزمن الواقعي للمسار كاملاً: من أسبوعين إلى أربعة أسابيع من العمل المنتظم.</a:t>
             </a:r>
           </a:p>
         </p:txBody>
@@ -873,7 +873,7 @@
           <a:lstStyle/>
           <a:p>
             <a:r>
-              <a:t>المرحلة الأخيرة: تحويل الملاحظة إلى فجوة علمية مصاغة باحترافية. القالب المعياري أربعة عناصر: (X) ما تناولته الدراسات فعلاً — يثبت اطلاعك على الأدبيات، (Y) الجانب الغائب — جوهر الفجوة، (Z) السياق المحدد — يمنحها حدوداً واقعية، ثم نوع الدراسة المقترحة — يحولها إلى خطة عمل. المثال المطبق مبني على المثال القوي الذي ذكرته الورشة (الدراسة عن بعد والقلق عند طلاب الجامعات العربية بعد 2020). وقبل الاعتماد النهائي مرر فجوتك على قائمة الفحص الخماسية: موثقة، محددة، مهمة، قابلة للمعالجة، وجديدة. إن اجتازت الخمسة فهي جاهزة لتتصدر مقدمة مقترحك البحثي وتصمد أمام المناقشة.</a:t>
+              <a:t>المرحلة الأخيرة: تحويل الملاحظة إلى فجوة علمية مصاغة باحترافية. القالب المعياري أربعة عناصر: (X) ما تناولته الدراسات فعلاً — يثبت اطلاعك على الأدبيات، (Y) الجانب الغائب — جوهر الفجوة، (Z) السياق المحدد — يمنحها حدوداً واقعية، ثم نوع الدراسة المقترحة — يحولها إلى خطة عمل. المثال المطبق يوضح كيفية ملء العناصر الأربعة بمحتوى حقيقي. وقبل الاعتماد النهائي مرر فجوتك على قائمة الفحص الخماسية: موثقة، محددة، مهمة، قابلة للمعالجة، وجديدة. إن اجتازت الخمسة فهي جاهزة لتتصدر مقدمة مقترحك البحثي وتصمد أمام المناقشة.</a:t>
             </a:r>
           </a:p>
         </p:txBody>
@@ -943,7 +943,7 @@
           <a:lstStyle/>
           <a:p>
             <a:r>
-              <a:t>الخلاصة كما وردت في ختام الورشة: الفجوة البحثية (Research Gap) هي أساس أي بحث علمي ناجح. تذكّر الرسائل الأربع: (1) الفجوة أساس البحث وجواز مرورك للأصالة والنشر والتمويل. (2) الأنواع الستة إطارك العملي — لكل نوع سؤاله المفتاحي وبابه الخاص. (3) استخدم أدوات الذكاء الاصطناعي بالطريقة الصحيحة: ارفع الملفات، اسأل بدقة، ثم راجع التحليل بنفسك قبل اعتماده. (4) اجعل فجوتك قوية: محددة وموثقة ومهمة وقابلة للمعالجة. وتختم الورشة بالرسالة الأجمل: الباحث المتميز ليس الشخص الذي يجد الإجابات فقط، لكنه الشخص الذي يطرح أسئلة لم يفكر فيها أحد من قبل. بالتوفيق في رحلتك البحثية!</a:t>
+              <a:t>الخلاصة: الفجوة البحثية (Research Gap) هي أساس أي بحث علمي ناجح. تذكّر الرسائل الأربع: (1) الفجوة أساس البحث وجواز مرورك للأصالة والنشر والتمويل. (2) الأنواع الستة إطارك العملي — لكل نوع سؤاله المفتاحي وبابه الخاص. (3) استخدم أدوات الذكاء الاصطناعي بالطريقة الصحيحة: ارفع الملفات، اسأل بدقة، ثم راجع التحليل بنفسك قبل اعتماده. (4) اجعل فجوتك قوية: محددة وموثقة ومهمة وقابلة للمعالجة. والرسالة الأجمل: الباحث المتميز ليس الشخص الذي يجد الإجابات فقط، لكنه الشخص الذي يطرح أسئلة لم يفكر فيها أحد من قبل. بالتوفيق في رحلتك البحثية!</a:t>
             </a:r>
           </a:p>
         </p:txBody>
@@ -1013,7 +1013,7 @@
           <a:lstStyle/>
           <a:p>
             <a:r>
-              <a:t>خطة العرض في سبعة محاور تتدرج منطقياً: نبدأ بالمفهوم (ما هي الفجوة وما صورها؟)، ثم الأهمية (لماذا نهتم؟)، ثم الأنواع الستة بشرح موسّع لكل نوع، ثم أمثلة تطبيقية واقعية، ثم ننتقل للجانب العملي: أدوات الذكاء الاصطناعي الثماني وسير العمل الذكي الذي أوصت به الورشة، فاستراتيجيات الباحثين المحترفين وإطار التفكير النقدي، ونختم بالتمييز بين الفجوة القوية والضعيفة وقالب صياغة جاهز للاستخدام. الهدف المعلن في الورشة: أن يخرج كل طالب وباحث قادراً على تحديد فجوة بحثية قوية باحترافية.</a:t>
+              <a:t>خطة العرض في سبعة محاور تتدرج منطقياً: نبدأ بالمفهوم (ما هي الفجوة وما صورها؟)، ثم الأهمية (لماذا نهتم؟)، ثم الأنواع الستة بشرح موسّع لكل نوع، ثم أمثلة تطبيقية واقعية، ثم ننتقل للجانب العملي: أدوات الذكاء الاصطناعي الثماني وسير العمل الذكي الموصى به، فاستراتيجيات الباحثين المحترفين وإطار التفكير النقدي، ونختم بالتمييز بين الفجوة القوية والضعيفة وقالب صياغة جاهز للاستخدام. الهدف: أن يخرج كل طالب وباحث قادراً على تحديد فجوة بحثية قوية باحترافية.</a:t>
             </a:r>
           </a:p>
         </p:txBody>
@@ -1083,7 +1083,7 @@
           <a:lstStyle/>
           <a:p>
             <a:r>
-              <a:t>من شرح الورشة: ماذا نقصد بالفجوة البحثية؟ ببساطة: منطقة أو مشكلة في مجال معين، إما أن أحداً لم يدرسها من قبل، أو دُرست بشكل ناقص، أو تحتاج مزيداً من التحليل والاستكشاف. وللفجوة أكثر من صورة: (1) موضوع جديد بالكامل لم يبحثه أحد — أقرب لفجوة المعرفة. (2) دراسة جزئية: الموضوع تناوله الباحثون من زاوية واحدة فقط. (3) نتائج متضاربة بين الدراسات تحتاج بحثاً يحسمها. (4) اختلاف السياق الجغرافي — وأكدت الشارحة هذه النقطة بمثال واضح: الدراسة التي تنجح في دولة معينة ليس شرطاً أن تنجح بنفس الطريقة في مجتمع آخر، لاختلاف الثقافة والظروف والبيئة. لذلك إعادة اختبار النتائج في سياقك المحلي فجوة مشروعة وقيّمة.</a:t>
+              <a:t>ماذا نقصد بالفجوة البحثية؟ ببساطة: منطقة أو مشكلة في مجال معين، إما أن أحداً لم يدرسها من قبل، أو دُرست بشكل ناقص، أو تحتاج مزيداً من التحليل والاستكشاف. وللفجوة أكثر من صورة: (1) موضوع جديد بالكامل لم يبحثه أحد — أقرب لفجوة المعرفة. (2) دراسة جزئية: الموضوع تناوله الباحثون من زاوية واحدة فقط. (3) نتائج متضاربة بين الدراسات تحتاج بحثاً يحسمها. (4) اختلاف السياق الجغرافي — ومثالها الواضح: الدراسة التي تنجح في دولة معينة ليس شرطاً أن تنجح بنفس الطريقة في مجتمع آخر، لاختلاف الثقافة والظروف والبيئة. لذلك إعادة اختبار النتائج في سياقك المحلي فجوة مشروعة وقيّمة.</a:t>
             </a:r>
           </a:p>
         </p:txBody>
@@ -1153,7 +1153,7 @@
           <a:lstStyle/>
           <a:p>
             <a:r>
-              <a:t>لماذا الفجوات البحثية مهمة جداً في البحث العلمي؟ كما عدّدتها الورشة: (1) تعطيك Research Direction — اتجاهاً واضحاً لبحثك. (2) تحقق Scientific Originality — الأصالة العلمية، أي أن بحثك فيه إضافة جديدة. (3) تساعدك في Justifying the Study — تبرير دراستك أمام اللجنة العلمية عندما تُسأل: لماذا هذا البحث؟ (4) تربط بين الـ Literature Review (الدراسات السابقة) وبين الشيء الجديد الذي ستضيفه — فيظهر بحثك امتداداً منطقياً للمعرفة. (5) حتى المجلات العلمية المحكّمة تفضّل الأبحاث التي تعالج فجوات واضحة — ذكر الفجوة في المقدمة يرفع حظوظ القبول. (6) والجهات الممولة للبحوث تبحث دائماً عن مشاكل حقيقية تحتاج حلولاً — الفجوة الموثقة هي ما يقنعها بالاستثمار في مقترحك.</a:t>
+              <a:t>لماذا الفجوات البحثية مهمة جداً في البحث العلمي؟ (1) تعطيك Research Direction — اتجاهاً واضحاً لبحثك. (2) تحقق Scientific Originality — الأصالة العلمية، أي أن بحثك فيه إضافة جديدة. (3) تساعدك في Justifying the Study — تبرير دراستك أمام اللجنة العلمية عندما تُسأل: لماذا هذا البحث؟ (4) تربط بين الـ Literature Review (الدراسات السابقة) وبين الشيء الجديد الذي ستضيفه — فيظهر بحثك امتداداً منطقياً للمعرفة. (5) حتى المجلات العلمية المحكّمة تفضّل الأبحاث التي تعالج فجوات واضحة — ذكر الفجوة في المقدمة يرفع حظوظ القبول. (6) والجهات الممولة للبحوث تبحث دائماً عن مشاكل حقيقية تحتاج حلولاً — الفجوة الموثقة هي ما يقنعها بالاستثمار في مقترحك.</a:t>
             </a:r>
           </a:p>
         </p:txBody>
@@ -1223,7 +1223,7 @@
           <a:lstStyle/>
           <a:p>
             <a:r>
-              <a:t>الأنواع الثلاثة الأولى كما شرحتها الورشة: (1) فجوة المعرفة Knowledge Gap: معلومة لا يعرفها العلم إلى الآن — يكون الموضوع جديداً بالكامل. مثالها النموذجي: الظواهر والتقنيات المستجدة. (2) فجوة الممارسة Practice Gap: الفرق بين النظرية وتطبيق الواقع — الإرشادات موجودة لكن الميدان لا يلتزم بها، والبحث يدرس الأسباب وسبل العلاج. هذا النوع مثالي للتخصصات المهنية كالتمريض والتعليم والإدارة. (3) فجوة الأدلة Evidence Gap: الأدلة العلمية غير كافية لدعم فرضية أو توصية — البحث هنا يصمم التجارب التي تبني الدليل الغائب. احفظ السؤال المفتاحي أسفل كل بطاقة؛ فهو أسرع وسيلة لاستدعاء النوع أثناء قراءتك للأدبيات.</a:t>
+              <a:t>الأنواع الثلاثة الأولى: (1) فجوة المعرفة Knowledge Gap: معلومة لا يعرفها العلم إلى الآن — يكون الموضوع جديداً بالكامل. مثالها النموذجي: الظواهر والتقنيات المستجدة. (2) فجوة الممارسة Practice Gap: الفرق بين النظرية وتطبيق الواقع — الإرشادات موجودة لكن الميدان لا يلتزم بها، والبحث يدرس الأسباب وسبل العلاج. هذا النوع مثالي للتخصصات المهنية كالتمريض والتعليم والإدارة. (3) فجوة الأدلة Evidence Gap: الأدلة العلمية غير كافية لدعم فرضية أو توصية — البحث هنا يصمم التجارب التي تبني الدليل الغائب. احفظ السؤال المفتاحي أسفل كل بطاقة؛ فهو أسرع وسيلة لاستدعاء النوع أثناء قراءتك للأدبيات.</a:t>
             </a:r>
           </a:p>
         </p:txBody>
@@ -1363,7 +1363,7 @@
           <a:lstStyle/>
           <a:p>
             <a:r>
-              <a:t>أمثلة عملية كما وردت في الورشة: في فجوة المعرفة — تأثير الذكاء الاصطناعي على القرارات الأخلاقية في القطاع الصحي العربي لم يُدرس بشكل كافٍ. في فجوة الممارسة — البروتوكولات الطبية موجودة لكن التطبيق الواقعي مختلف. في فجوة السكان — معظم الدراسات على طلاب غربيين والشباب العربي ما زال ناقصاً في الدراسات. في الفجوة المنهجية — كل الدراسات استخدمت المنهج الكمي فقط بينما النوعي يعطي تفاصيل أعمق. في الفجوة الزمنية — الدراسات قبل 2020 لا تعكس تغيرات ما بعد الجائحة. وأضفنا مثالاً لفجوة الأدلة: التوصية الشائعة بالتعلم المصغّر دون تجارب مضبوطة. لاحظ البنية المشتركة في كل مثال: موضوع + سياق + سبب اعتباره فجوة — استخدم البنية نفسها عند صياغة فجوتك.</a:t>
+              <a:t>أمثلة عملية: في فجوة المعرفة — تأثير الذكاء الاصطناعي على القرارات الأخلاقية في القطاع الصحي العربي لم يُدرس بشكل كافٍ. في فجوة الممارسة — البروتوكولات الطبية موجودة لكن التطبيق الواقعي مختلف. في فجوة السكان — معظم الدراسات على طلاب غربيين والشباب العربي ما زال ناقصاً في الدراسات. في الفجوة المنهجية — كل الدراسات استخدمت المنهج الكمي فقط بينما النوعي يعطي تفاصيل أعمق. في الفجوة الزمنية — الدراسات قبل 2020 لا تعكس تغيرات ما بعد الجائحة. وفي فجوة الأدلة: التوصية الشائعة بالتعلم المصغّر دون تجارب مضبوطة. لاحظ البنية المشتركة في كل مثال: موضوع + سياق + سبب اعتباره فجوة — استخدم البنية نفسها عند صياغة فجوتك.</a:t>
             </a:r>
           </a:p>
         </p:txBody>
@@ -1433,7 +1433,7 @@
           <a:lstStyle/>
           <a:p>
             <a:r>
-              <a:t>مع تطور التكنولوجيا صارت لدينا أدوات ذكاء اصطناعي قوية تساعد الباحث على اكتشاف الفجوات بسرعة. كما عرضتها الورشة بالترتيب: Elicit يلخص الدراسات، Consensus يعطي إجماع الأبحاث حول سؤال معين، Research Rabbit يرسم خريطة للعلاقات بين الأبحاث، Connected Papers يوضح الدراسات المرتبطة، Scite.ai يقيّم قوة المراجع، Semantic Scholar محرك بحث أكاديمي ذكي، Claude يقدم تحليلاً وحواراً نقدياً معمقاً، وChatGPT يساعد في الفهم العام. وشددت الورشة على أن الأقوى بينها هو Research Rabbit لقدرته على رسم خريطة واضحة للعلاقات — وخصصنا الشريحة التالية لسير العمل الموصى به معه خطوة بخطوة.</a:t>
+              <a:t>مع تطور التكنولوجيا صارت لدينا أدوات ذكاء اصطناعي قوية تساعد الباحث على اكتشاف الفجوات بسرعة. بالترتيب: Elicit يلخص الدراسات، Consensus يعطي إجماع الأبحاث حول سؤال معين، Research Rabbit يرسم خريطة للعلاقات بين الأبحاث، Connected Papers يوضح الدراسات المرتبطة، Scite.ai يقيّم قوة المراجع، Semantic Scholar محرك بحث أكاديمي ذكي، Claude يقدم تحليلاً وحواراً نقدياً معمقاً، وChatGPT يساعد في الفهم العام. والأقوى بينها Research Rabbit لقدرته على رسم خريطة واضحة للعلاقات — والشريحة التالية تعرض سير العمل الموصى به معه خطوة بخطوة.</a:t>
             </a:r>
           </a:p>
         </p:txBody>
@@ -1503,7 +1503,7 @@
           <a:lstStyle/>
           <a:p>
             <a:r>
-              <a:t>هذه الشريحة تلخص أهم إضافة عملية في شرح الورشة — سير العمل الموصى به مع Research Rabbit: (1) يرفع الباحث ملفات الدراسات المرتبطة بموضوعه إلى المنصة. (2) يسأل سؤالاً دقيقاً: «حلّل هذه الملفات واستخرج الفجوة البحثية». (3) ثم — وهذه النقطة التي شددت عليها الورشة — يراجع الباحث التحليل الذي قدمه الذكاء الاصطناعي بنفسه، لضمان دقة القرار الأكاديمي. (4) بعد التحقق يعتمد الفجوة ويبني عليها مقترحه. الرسالة الجوهرية: الأدوات الذكية تسرّع الاكتشاف لكنها لا تلغي دور الباحث — الحكم النهائي دائماً للعقل النقدي البشري وللمصادر الأصلية.</a:t>
+              <a:t>سير العمل الموصى به مع Research Rabbit: (1) يرفع الباحث ملفات الدراسات المرتبطة بموضوعه إلى المنصة. (2) يسأل سؤالاً دقيقاً: «حلّل هذه الملفات واستخرج الفجوة البحثية». (3) ثم يراجع الباحث التحليل الذي قدمه الذكاء الاصطناعي بنفسه، لضمان دقة القرار الأكاديمي. (4) بعد التحقق يعتمد الفجوة ويبني عليها مقترحه. الرسالة الجوهرية: الأدوات الذكية تسرّع الاكتشاف لكنها لا تلغي دور الباحث — الحكم النهائي دائماً للعقل النقدي البشري وللمصادر الأصلية.</a:t>
             </a:r>
           </a:p>
         </p:txBody>
@@ -5084,7 +5084,7 @@
                 <a:cs typeface="Noto Sans Arabic"/>
                 <a:ea typeface="Noto Sans Arabic"/>
               </a:rPr>
-              <a:t>دليلك الشامل لاكتشاف الفجوات البحثية بذكاء واحترافية — نسخة موسّعة من الشرح الكامل للورشة</a:t>
+              <a:t>دليلك الشامل لاكتشاف الفجوات البحثية بذكاء واحترافية</a:t>
             </a:r>
           </a:p>
         </p:txBody>
@@ -5296,53 +5296,6 @@
                 <a:ea typeface="Noto Sans Arabic"/>
               </a:rPr>
               <a:t>   Dr. Hana Hossen Elahemer</a:t>
-            </a:r>
-          </a:p>
-        </p:txBody>
-      </p:sp>
-      <p:sp>
-        <p:nvSpPr>
-          <p:cNvPr id="18" name="TextBox 17"/>
-          <p:cNvSpPr txBox="1"/>
-          <p:nvPr/>
-        </p:nvSpPr>
-        <p:spPr>
-          <a:xfrm>
-            <a:off x="1371600" y="6035040"/>
-            <a:ext cx="9448495" cy="365760"/>
-          </a:xfrm>
-          <a:prstGeom prst="rect">
-            <a:avLst/>
-          </a:prstGeom>
-          <a:noFill/>
-        </p:spPr>
-        <p:txBody>
-          <a:bodyPr wrap="square" anchor="t" lIns="0" rIns="0" tIns="0" bIns="0">
-            <a:spAutoFit/>
-          </a:bodyPr>
-          <a:lstStyle/>
-          <a:p>
-            <a:pPr algn="ctr" rtl="1">
-              <a:lnSpc>
-                <a:spcPct val="105000"/>
-              </a:lnSpc>
-              <a:spcBef>
-                <a:spcPts val="0"/>
-              </a:spcBef>
-              <a:spcAft>
-                <a:spcPts val="400"/>
-              </a:spcAft>
-            </a:pPr>
-            <a:r>
-              <a:rPr sz="1100" b="0" i="0">
-                <a:solidFill>
-                  <a:srgbClr val="FFFFFF"/>
-                </a:solidFill>
-                <a:latin typeface="Noto Sans Arabic"/>
-                <a:cs typeface="Noto Sans Arabic"/>
-                <a:ea typeface="Noto Sans Arabic"/>
-              </a:rPr>
-              <a:t>نسخة موسّعة بشرح تفصيلي أكبر وتصميم جديد</a:t>
             </a:r>
           </a:p>
         </p:txBody>
@@ -8359,18 +8312,7 @@
                 <a:cs typeface="Noto Sans Arabic"/>
                 <a:ea typeface="Noto Sans Arabic"/>
               </a:rPr>
-              <a:t>«التفكير النقدي لا يعني أن ننتقد الدراسات السابقة — بل أن نبني عليها ونطوّرها»  </a:t>
-            </a:r>
-            <a:r>
-              <a:rPr sz="1100" b="0" i="0">
-                <a:solidFill>
-                  <a:srgbClr val="6E6A8F"/>
-                </a:solidFill>
-                <a:latin typeface="Noto Sans Arabic"/>
-                <a:cs typeface="Noto Sans Arabic"/>
-                <a:ea typeface="Noto Sans Arabic"/>
-              </a:rPr>
-              <a:t>— من شرح الورشة</a:t>
+              <a:t>«التفكير النقدي لا يعني أن ننتقد الدراسات السابقة — بل أن نبني عليها ونطوّرها»</a:t>
             </a:r>
           </a:p>
         </p:txBody>
@@ -9779,7 +9721,7 @@
                 <a:cs typeface="Noto Sans Arabic"/>
                 <a:ea typeface="Noto Sans Arabic"/>
               </a:rPr>
-              <a:t>🧪 المثال المقارن من الورشة —  </a:t>
+              <a:t>🧪 مثال مقارن —  </a:t>
             </a:r>
             <a:r>
               <a:rPr sz="1250" b="1" i="0">
@@ -12811,7 +12753,7 @@
                 <a:cs typeface="Noto Sans Arabic"/>
                 <a:ea typeface="Noto Sans Arabic"/>
               </a:rPr>
-              <a:t>✅ مثال مطبَّق بأسلوب الورشة:  </a:t>
+              <a:t>✅ مثال مطبَّق:  </a:t>
             </a:r>
             <a:r>
               <a:rPr sz="1250" b="0" i="0">
@@ -15230,17 +15172,6 @@
               </a:rPr>
               <a:t>الدكتورة هناء حسين الأهيمر</a:t>
             </a:r>
-            <a:r>
-              <a:rPr sz="1100" b="0" i="0">
-                <a:solidFill>
-                  <a:srgbClr val="FFFFFF"/>
-                </a:solidFill>
-                <a:latin typeface="Noto Sans Arabic"/>
-                <a:cs typeface="Noto Sans Arabic"/>
-                <a:ea typeface="Noto Sans Arabic"/>
-              </a:rPr>
-              <a:t>  •  نسخة موسّعة بتصميم جديد</a:t>
-            </a:r>
           </a:p>
         </p:txBody>
       </p:sp>
@@ -16060,7 +15991,7 @@
                 <a:cs typeface="Noto Sans Arabic"/>
                 <a:ea typeface="Noto Sans Arabic"/>
               </a:rPr>
-              <a:t>التعريف الدقيق وصورها الأربع كما شرحتها الورشة</a:t>
+              <a:t>التعريف الدقيق والصور الأربع التي تظهر بها الفجوات</a:t>
             </a:r>
           </a:p>
         </p:txBody>
@@ -17388,7 +17319,7 @@
         <p:spPr>
           <a:xfrm>
             <a:off x="777240" y="5568696"/>
-            <a:ext cx="4884267" cy="640080"/>
+            <a:ext cx="4884267" cy="603504"/>
           </a:xfrm>
           <a:prstGeom prst="rect">
             <a:avLst/>
@@ -17396,34 +17327,10 @@
           <a:noFill/>
         </p:spPr>
         <p:txBody>
-          <a:bodyPr wrap="square" anchor="t" lIns="0" rIns="0" tIns="0" bIns="0">
+          <a:bodyPr wrap="square" anchor="ctr" lIns="0" rIns="0" tIns="0" bIns="0">
             <a:spAutoFit/>
           </a:bodyPr>
           <a:lstStyle/>
-          <a:p>
-            <a:pPr algn="ctr" rtl="1">
-              <a:lnSpc>
-                <a:spcPct val="105000"/>
-              </a:lnSpc>
-              <a:spcBef>
-                <a:spcPts val="0"/>
-              </a:spcBef>
-              <a:spcAft>
-                <a:spcPts val="200"/>
-              </a:spcAft>
-            </a:pPr>
-            <a:r>
-              <a:rPr sz="1300" b="1" i="0">
-                <a:solidFill>
-                  <a:srgbClr val="6D28D9"/>
-                </a:solidFill>
-                <a:latin typeface="Noto Sans Arabic"/>
-                <a:cs typeface="Noto Sans Arabic"/>
-                <a:ea typeface="Noto Sans Arabic"/>
-              </a:rPr>
-              <a:t>«الفجوة البحثية هي أساس أي بحث علمي ناجح»</a:t>
-            </a:r>
-          </a:p>
           <a:p>
             <a:pPr algn="ctr" rtl="1">
               <a:lnSpc>
@@ -17437,15 +17344,15 @@
               </a:spcAft>
             </a:pPr>
             <a:r>
-              <a:rPr sz="1000" b="0" i="0">
-                <a:solidFill>
-                  <a:srgbClr val="6E6A8F"/>
-                </a:solidFill>
-                <a:latin typeface="Noto Sans Arabic"/>
-                <a:cs typeface="Noto Sans Arabic"/>
-                <a:ea typeface="Noto Sans Arabic"/>
-              </a:rPr>
-              <a:t>— من خلاصة الورشة</a:t>
+              <a:rPr sz="1300" b="1" i="0">
+                <a:solidFill>
+                  <a:srgbClr val="6D28D9"/>
+                </a:solidFill>
+                <a:latin typeface="Noto Sans Arabic"/>
+                <a:cs typeface="Noto Sans Arabic"/>
+                <a:ea typeface="Noto Sans Arabic"/>
+              </a:rPr>
+              <a:t>«الفجوة البحثية هي أساس أي بحث علمي ناجح»</a:t>
             </a:r>
           </a:p>
         </p:txBody>
@@ -18092,7 +17999,7 @@
                 <a:cs typeface="Noto Sans Arabic"/>
                 <a:ea typeface="Noto Sans Arabic"/>
               </a:rPr>
-              <a:t>التعريف كما ورد في الشرح:  </a:t>
+              <a:t>التعريف:  </a:t>
             </a:r>
             <a:r>
               <a:rPr sz="1400" b="0" i="0">
@@ -22224,7 +22131,7 @@
                 <a:cs typeface="Noto Sans Arabic"/>
                 <a:ea typeface="Noto Sans Arabic"/>
               </a:rPr>
-              <a:t>من شرح الورشة:  </a:t>
+              <a:t>توضيح:  </a:t>
             </a:r>
             <a:r>
               <a:rPr sz="1200" b="0" i="0">
@@ -22658,7 +22565,7 @@
                 <a:cs typeface="Noto Sans Arabic"/>
                 <a:ea typeface="Noto Sans Arabic"/>
               </a:rPr>
-              <a:t>من شرح الورشة:  </a:t>
+              <a:t>توضيح:  </a:t>
             </a:r>
             <a:r>
               <a:rPr sz="1200" b="0" i="0">
@@ -23092,7 +22999,7 @@
                 <a:cs typeface="Noto Sans Arabic"/>
                 <a:ea typeface="Noto Sans Arabic"/>
               </a:rPr>
-              <a:t>من شرح الورشة:  </a:t>
+              <a:t>توضيح:  </a:t>
             </a:r>
             <a:r>
               <a:rPr sz="1200" b="0" i="0">
@@ -24065,7 +23972,7 @@
                 <a:cs typeface="Noto Sans Arabic"/>
                 <a:ea typeface="Noto Sans Arabic"/>
               </a:rPr>
-              <a:t>من شرح الورشة:  </a:t>
+              <a:t>توضيح:  </a:t>
             </a:r>
             <a:r>
               <a:rPr sz="1200" b="0" i="0">
@@ -24499,7 +24406,7 @@
                 <a:cs typeface="Noto Sans Arabic"/>
                 <a:ea typeface="Noto Sans Arabic"/>
               </a:rPr>
-              <a:t>من شرح الورشة:  </a:t>
+              <a:t>توضيح:  </a:t>
             </a:r>
             <a:r>
               <a:rPr sz="1200" b="0" i="0">
@@ -24933,7 +24840,7 @@
                 <a:cs typeface="Noto Sans Arabic"/>
                 <a:ea typeface="Noto Sans Arabic"/>
               </a:rPr>
-              <a:t>من شرح الورشة:  </a:t>
+              <a:t>توضيح:  </a:t>
             </a:r>
             <a:r>
               <a:rPr sz="1200" b="0" i="0">
@@ -27982,7 +27889,7 @@
                 <a:cs typeface="Noto Sans Arabic"/>
                 <a:ea typeface="Noto Sans Arabic"/>
               </a:rPr>
-              <a:t>يرسم خريطة للعلاقات بين الأبحاث — الأقوى بحسب الورشة</a:t>
+              <a:t>يرسم خريطة للعلاقات بين الأبحاث ويكشف مواضع الفراغ</a:t>
             </a:r>
           </a:p>
         </p:txBody>
@@ -29245,7 +29152,7 @@
                 <a:cs typeface="Noto Sans Arabic"/>
                 <a:ea typeface="Noto Sans Arabic"/>
               </a:rPr>
-              <a:t>💡 من الشرح: </a:t>
+              <a:t>💡 نصيحة: </a:t>
             </a:r>
             <a:r>
               <a:rPr sz="1200" b="0" i="0">
@@ -29256,7 +29163,7 @@
                 <a:cs typeface="Noto Sans Arabic"/>
                 <a:ea typeface="Noto Sans Arabic"/>
               </a:rPr>
-              <a:t>الأدوات كثيرة، لكن الأقوى هو Research Rabbit لأنه يرسم خريطة واضحة للعلاقات بين الأبحاث — وسير العمل معه في الشريحة التالية</a:t>
+              <a:t>الأدوات كثيرة، والأقوى Research Rabbit لأنه يرسم خريطة واضحة للعلاقات بين الأبحاث — وسير العمل معه في الشريحة التالية</a:t>
             </a:r>
           </a:p>
         </p:txBody>
@@ -29795,7 +29702,7 @@
                 <a:cs typeface="Noto Sans Arabic"/>
                 <a:ea typeface="Noto Sans Arabic"/>
               </a:rPr>
-              <a:t>الطريقة العملية التي أوصت بها الورشة لاستخراج الفجوة بالذكاء الاصطناعي — أربع خطوات:</a:t>
+              <a:t>الطريقة العملية لاستخراج الفجوة البحثية بالذكاء الاصطناعي — أربع خطوات:</a:t>
             </a:r>
           </a:p>
         </p:txBody>

</xml_diff>